<commit_message>
Review_Presentation.pptx: flatten nested parens + NMQ 4-area disclosure
Slide 10 Posture recommendation: flatten the doubly-nested "(84% at RULA
grand score 5+ (action level 3 or 4))" to a comma-joined single paren.

Slide 4 Q19: name the four rider-relevant NMQ 7-day areas (neck, lower
back, wrist/hands, knees) so the deck matches the report's disclosure
that the standard 9-region NMQ is truncated to 4 areas.
</commit_message>
<xml_diff>
--- a/deck/Review_Presentation.pptx
+++ b/deck/Review_Presentation.pptx
@@ -3952,7 +3952,7 @@
                 </a:solidFill>
                 <a:latin typeface="Calibri"/>
               </a:rPr>
-              <a:t>•   Posture training and equipment review (84% at RULA grand score 5+ (action level 3 or 4)).</a:t>
+              <a:t>•   Posture training and equipment review (84% at RULA grand score 5+, action level 3 or 4).</a:t>
             </a:r>
           </a:p>
           <a:p>
@@ -5397,7 +5397,7 @@
                 </a:solidFill>
                 <a:latin typeface="Calibri"/>
               </a:rPr>
-              <a:t>–   </a:t>
+              <a:t>–   Q19: 7-day discomfort (neck, lower back, wrist/hands, knees)</a:t>
             </a:r>
             <a:r>
               <a:rPr sz="1200" b="0" i="0">
@@ -5406,7 +5406,7 @@
                 </a:solidFill>
                 <a:latin typeface="Calibri"/>
               </a:rPr>
-              <a:t>Q19: 7-day discomfort (4 areas)</a:t>
+              <a:t/>
             </a:r>
           </a:p>
           <a:p>

</xml_diff>

<commit_message>
Review_Presentation.pptx: sync latest edits
</commit_message>
<xml_diff>
--- a/deck/Review_Presentation.pptx
+++ b/deck/Review_Presentation.pptx
@@ -15,6 +15,7 @@
     <p:sldId id="263" r:id="rId9"/>
     <p:sldId id="264" r:id="rId10"/>
     <p:sldId id="265" r:id="rId11"/>
+    <p:sldId id="266" r:id="rId12"/>
   </p:sldIdLst>
   <p:sldSz cx="12192000" cy="6858000"/>
   <p:notesSz cx="6858000" cy="9144000"/>
@@ -311,7 +312,7 @@
           <a:p>
             <a:fld id="{5BCAD085-E8A6-8845-BD4E-CB4CCA059FC4}" type="datetimeFigureOut">
               <a:rPr lang="en-US" smtClean="0"/>
-              <a:t>10-Jul-26</a:t>
+              <a:t>13-Jul-26</a:t>
             </a:fld>
             <a:endParaRPr lang="en-US"/>
           </a:p>
@@ -479,7 +480,7 @@
           <a:p>
             <a:fld id="{5BCAD085-E8A6-8845-BD4E-CB4CCA059FC4}" type="datetimeFigureOut">
               <a:rPr lang="en-US" smtClean="0"/>
-              <a:t>10-Jul-26</a:t>
+              <a:t>13-Jul-26</a:t>
             </a:fld>
             <a:endParaRPr lang="en-US"/>
           </a:p>
@@ -657,7 +658,7 @@
           <a:p>
             <a:fld id="{5BCAD085-E8A6-8845-BD4E-CB4CCA059FC4}" type="datetimeFigureOut">
               <a:rPr lang="en-US" smtClean="0"/>
-              <a:t>10-Jul-26</a:t>
+              <a:t>13-Jul-26</a:t>
             </a:fld>
             <a:endParaRPr lang="en-US"/>
           </a:p>
@@ -825,7 +826,7 @@
           <a:p>
             <a:fld id="{5BCAD085-E8A6-8845-BD4E-CB4CCA059FC4}" type="datetimeFigureOut">
               <a:rPr lang="en-US" smtClean="0"/>
-              <a:t>10-Jul-26</a:t>
+              <a:t>13-Jul-26</a:t>
             </a:fld>
             <a:endParaRPr lang="en-US"/>
           </a:p>
@@ -1070,7 +1071,7 @@
           <a:p>
             <a:fld id="{5BCAD085-E8A6-8845-BD4E-CB4CCA059FC4}" type="datetimeFigureOut">
               <a:rPr lang="en-US" smtClean="0"/>
-              <a:t>10-Jul-26</a:t>
+              <a:t>13-Jul-26</a:t>
             </a:fld>
             <a:endParaRPr lang="en-US"/>
           </a:p>
@@ -1355,7 +1356,7 @@
           <a:p>
             <a:fld id="{5BCAD085-E8A6-8845-BD4E-CB4CCA059FC4}" type="datetimeFigureOut">
               <a:rPr lang="en-US" smtClean="0"/>
-              <a:t>10-Jul-26</a:t>
+              <a:t>13-Jul-26</a:t>
             </a:fld>
             <a:endParaRPr lang="en-US"/>
           </a:p>
@@ -1774,7 +1775,7 @@
           <a:p>
             <a:fld id="{5BCAD085-E8A6-8845-BD4E-CB4CCA059FC4}" type="datetimeFigureOut">
               <a:rPr lang="en-US" smtClean="0"/>
-              <a:t>10-Jul-26</a:t>
+              <a:t>13-Jul-26</a:t>
             </a:fld>
             <a:endParaRPr lang="en-US"/>
           </a:p>
@@ -1891,7 +1892,7 @@
           <a:p>
             <a:fld id="{5BCAD085-E8A6-8845-BD4E-CB4CCA059FC4}" type="datetimeFigureOut">
               <a:rPr lang="en-US" smtClean="0"/>
-              <a:t>10-Jul-26</a:t>
+              <a:t>13-Jul-26</a:t>
             </a:fld>
             <a:endParaRPr lang="en-US"/>
           </a:p>
@@ -1986,7 +1987,7 @@
           <a:p>
             <a:fld id="{5BCAD085-E8A6-8845-BD4E-CB4CCA059FC4}" type="datetimeFigureOut">
               <a:rPr lang="en-US" smtClean="0"/>
-              <a:t>10-Jul-26</a:t>
+              <a:t>13-Jul-26</a:t>
             </a:fld>
             <a:endParaRPr lang="en-US"/>
           </a:p>
@@ -2261,7 +2262,7 @@
           <a:p>
             <a:fld id="{5BCAD085-E8A6-8845-BD4E-CB4CCA059FC4}" type="datetimeFigureOut">
               <a:rPr lang="en-US" smtClean="0"/>
-              <a:t>10-Jul-26</a:t>
+              <a:t>13-Jul-26</a:t>
             </a:fld>
             <a:endParaRPr lang="en-US"/>
           </a:p>
@@ -2513,7 +2514,7 @@
           <a:p>
             <a:fld id="{5BCAD085-E8A6-8845-BD4E-CB4CCA059FC4}" type="datetimeFigureOut">
               <a:rPr lang="en-US" smtClean="0"/>
-              <a:t>10-Jul-26</a:t>
+              <a:t>13-Jul-26</a:t>
             </a:fld>
             <a:endParaRPr lang="en-US"/>
           </a:p>
@@ -2724,7 +2725,7 @@
           <a:p>
             <a:fld id="{5BCAD085-E8A6-8845-BD4E-CB4CCA059FC4}" type="datetimeFigureOut">
               <a:rPr lang="en-US" smtClean="0"/>
-              <a:t>10-Jul-26</a:t>
+              <a:t>13-Jul-26</a:t>
             </a:fld>
             <a:endParaRPr lang="en-US"/>
           </a:p>
@@ -3744,7 +3745,7 @@
         <p:spPr>
           <a:xfrm>
             <a:off x="640080" y="2103120"/>
-            <a:ext cx="5760720" cy="2926080"/>
+            <a:ext cx="5760720" cy="2743200"/>
           </a:xfrm>
           <a:prstGeom prst="rect">
             <a:avLst/>
@@ -3763,7 +3764,7 @@
               </a:spcAft>
             </a:pPr>
             <a:r>
-              <a:rPr sz="1200" b="1" i="0">
+              <a:rPr sz="1200" b="1" i="0" dirty="0">
                 <a:solidFill>
                   <a:srgbClr val="0F766E"/>
                 </a:solidFill>
@@ -3772,13 +3773,13 @@
               <a:t>•   </a:t>
             </a:r>
             <a:r>
-              <a:rPr sz="1200" b="0" i="0">
+              <a:rPr sz="1200" b="0" i="0" dirty="0">
                 <a:solidFill>
                   <a:srgbClr val="1F2A40"/>
                 </a:solidFill>
                 <a:latin typeface="Calibri"/>
               </a:rPr>
-              <a:t>Two-stage pipeline auditable by ergonomists and ML reviewers independently.</a:t>
+              <a:t>Two-stage pipeline: independently auditable by domain experts and ML reviewers.</a:t>
             </a:r>
           </a:p>
           <a:p>
@@ -3788,7 +3789,7 @@
               </a:spcAft>
             </a:pPr>
             <a:r>
-              <a:rPr sz="1200" b="1" i="0">
+              <a:rPr sz="1200" b="1" i="0" dirty="0">
                 <a:solidFill>
                   <a:srgbClr val="0F766E"/>
                 </a:solidFill>
@@ -3797,13 +3798,13 @@
               <a:t>•   </a:t>
             </a:r>
             <a:r>
-              <a:rPr sz="1200" b="0" i="0">
+              <a:rPr sz="1200" b="0" i="0" dirty="0">
                 <a:solidFill>
                   <a:srgbClr val="1F2A40"/>
                 </a:solidFill>
                 <a:latin typeface="Calibri"/>
               </a:rPr>
-              <a:t>Six per-factor classifiers with honest 5-fold CV metrics.</a:t>
+              <a:t>Six per-factor classifiers with 5-fold CV metrics.</a:t>
             </a:r>
           </a:p>
           <a:p>
@@ -3813,7 +3814,7 @@
               </a:spcAft>
             </a:pPr>
             <a:r>
-              <a:rPr sz="1200" b="1" i="0">
+              <a:rPr sz="1200" b="1" i="0" dirty="0">
                 <a:solidFill>
                   <a:srgbClr val="0F766E"/>
                 </a:solidFill>
@@ -3822,13 +3823,31 @@
               <a:t>•   </a:t>
             </a:r>
             <a:r>
-              <a:rPr sz="1200" b="0" i="0">
+              <a:rPr sz="1200" b="0" i="0" dirty="0">
                 <a:solidFill>
                   <a:srgbClr val="1F2A40"/>
                 </a:solidFill>
                 <a:latin typeface="Calibri"/>
               </a:rPr>
-              <a:t>Two methodological corrections openly disclosed (Repetition qcut boundary, Duration leakage via vibration_index).</a:t>
+              <a:t>Two methodological corrections documented (Repetition </a:t>
+            </a:r>
+            <a:r>
+              <a:rPr sz="1200" b="0" i="0" dirty="0" err="1">
+                <a:solidFill>
+                  <a:srgbClr val="1F2A40"/>
+                </a:solidFill>
+                <a:latin typeface="Calibri"/>
+              </a:rPr>
+              <a:t>qcut</a:t>
+            </a:r>
+            <a:r>
+              <a:rPr sz="1200" b="0" i="0" dirty="0">
+                <a:solidFill>
+                  <a:srgbClr val="1F2A40"/>
+                </a:solidFill>
+                <a:latin typeface="Calibri"/>
+              </a:rPr>
+              <a:t>, Duration leakage).</a:t>
             </a:r>
           </a:p>
           <a:p>
@@ -3838,7 +3857,7 @@
               </a:spcAft>
             </a:pPr>
             <a:r>
-              <a:rPr sz="1200" b="1" i="0">
+              <a:rPr sz="1200" b="1" i="0" dirty="0">
                 <a:solidFill>
                   <a:srgbClr val="0F766E"/>
                 </a:solidFill>
@@ -3847,13 +3866,31 @@
               <a:t>•   </a:t>
             </a:r>
             <a:r>
-              <a:rPr sz="1200" b="0" i="0">
+              <a:rPr sz="1200" b="0" i="0" dirty="0">
                 <a:solidFill>
                   <a:srgbClr val="1F2A40"/>
                 </a:solidFill>
                 <a:latin typeface="Calibri"/>
               </a:rPr>
-              <a:t>Multi-page Streamlit web app for real-time screening.</a:t>
+              <a:t>Multi-page </a:t>
+            </a:r>
+            <a:r>
+              <a:rPr sz="1200" b="0" i="0" dirty="0" err="1">
+                <a:solidFill>
+                  <a:srgbClr val="1F2A40"/>
+                </a:solidFill>
+                <a:latin typeface="Calibri"/>
+              </a:rPr>
+              <a:t>Streamlit</a:t>
+            </a:r>
+            <a:r>
+              <a:rPr sz="1200" b="0" i="0" dirty="0">
+                <a:solidFill>
+                  <a:srgbClr val="1F2A40"/>
+                </a:solidFill>
+                <a:latin typeface="Calibri"/>
+              </a:rPr>
+              <a:t> web app for real-time screening.</a:t>
             </a:r>
           </a:p>
         </p:txBody>
@@ -3902,7 +3939,7 @@
         <p:spPr>
           <a:xfrm>
             <a:off x="6492240" y="2103120"/>
-            <a:ext cx="5212080" cy="2926080"/>
+            <a:ext cx="5212080" cy="2743200"/>
           </a:xfrm>
           <a:prstGeom prst="rect">
             <a:avLst/>
@@ -3936,7 +3973,7 @@
                 </a:solidFill>
                 <a:latin typeface="Calibri"/>
               </a:rPr>
-              <a:t>Cap daily hours (49% of sample &gt; 8 h/day).</a:t>
+              <a:t>Rider-app symptom check-in every 5 shifts, feeding back into screening.</a:t>
             </a:r>
           </a:p>
           <a:p>
@@ -3946,13 +3983,22 @@
               </a:spcAft>
             </a:pPr>
             <a:r>
-              <a:rPr sz="1200" b="1" i="0">
+              <a:rPr sz="1300" b="1" i="0">
                 <a:solidFill>
                   <a:srgbClr val="0F766E"/>
                 </a:solidFill>
                 <a:latin typeface="Calibri"/>
               </a:rPr>
-              <a:t>•   Posture training and equipment review (84% at RULA grand score 5+, action level 3 or 4).</a:t>
+              <a:t>•   </a:t>
+            </a:r>
+            <a:r>
+              <a:rPr sz="1300" b="0" i="0">
+                <a:solidFill>
+                  <a:srgbClr val="1F2A40"/>
+                </a:solidFill>
+                <a:latin typeface="Calibri"/>
+              </a:rPr>
+              <a:t>30-minute ergonomic onboarding for new riders (bike, posture, lifting).</a:t>
             </a:r>
           </a:p>
           <a:p>
@@ -3977,7 +4023,7 @@
                 </a:solidFill>
                 <a:latin typeface="Calibri"/>
               </a:rPr>
-              <a:t>Prefer bike-storage carriers over handheld bags.</a:t>
+              <a:t>Physiotherapy partnership for riders flagged High on 2+ factors.</a:t>
             </a:r>
           </a:p>
           <a:p>
@@ -4002,23 +4048,7 @@
                 </a:solidFill>
                 <a:latin typeface="Calibri"/>
               </a:rPr>
-              <a:t>Age-targeted MSD screening for 36+ cohort.</a:t>
-            </a:r>
-          </a:p>
-          <a:p>
-            <a:pPr algn="l">
-              <a:spcAft>
-                <a:spcPts val="600"/>
-              </a:spcAft>
-            </a:pPr>
-            <a:r>
-              <a:rPr sz="1200" b="1" i="0">
-                <a:solidFill>
-                  <a:srgbClr val="0F766E"/>
-                </a:solidFill>
-                <a:latin typeface="Calibri"/>
-              </a:rPr>
-              <a:t>•   Rotate riders through high-workload shifts; watch NASA-TLX and fatigue as leading indicators.</a:t>
+              <a:t>Internal rider-health dashboard alongside delivery-time KPIs.</a:t>
             </a:r>
           </a:p>
         </p:txBody>
@@ -4031,8 +4061,8 @@
         </p:nvSpPr>
         <p:spPr>
           <a:xfrm>
-            <a:off x="640080" y="5303520"/>
-            <a:ext cx="11064240" cy="960120"/>
+            <a:off x="685800" y="3941064"/>
+            <a:ext cx="11064240" cy="1810512"/>
           </a:xfrm>
           <a:prstGeom prst="rect">
             <a:avLst/>
@@ -4066,7 +4096,7 @@
           <a:lstStyle/>
           <a:p>
             <a:pPr algn="ctr"/>
-            <a:endParaRPr/>
+            <a:endParaRPr dirty="0"/>
           </a:p>
         </p:txBody>
       </p:sp>
@@ -4078,7 +4108,7 @@
         </p:nvSpPr>
         <p:spPr>
           <a:xfrm>
-            <a:off x="822960" y="5394960"/>
+            <a:off x="822960" y="3995928"/>
             <a:ext cx="10789920" cy="365760"/>
           </a:xfrm>
           <a:prstGeom prst="rect">
@@ -4094,7 +4124,7 @@
           <a:p>
             <a:pPr algn="l"/>
             <a:r>
-              <a:rPr sz="1100" b="1" i="0">
+              <a:rPr sz="1100" b="1" i="0" dirty="0">
                 <a:solidFill>
                   <a:srgbClr val="0F766E"/>
                 </a:solidFill>
@@ -4113,8 +4143,8 @@
         </p:nvSpPr>
         <p:spPr>
           <a:xfrm>
-            <a:off x="822960" y="5623560"/>
-            <a:ext cx="10972800" cy="640080"/>
+            <a:off x="822960" y="4191129"/>
+            <a:ext cx="10972800" cy="1448730"/>
           </a:xfrm>
           <a:prstGeom prst="rect">
             <a:avLst/>
@@ -4127,7 +4157,20 @@
           </a:bodyPr>
           <a:lstStyle/>
           <a:p>
-            <a:pPr algn="l"/>
+            <a:pPr algn="l">
+              <a:lnSpc>
+                <a:spcPct val="150000"/>
+              </a:lnSpc>
+            </a:pPr>
+            <a:r>
+              <a:rPr sz="1200" b="1" i="0" dirty="0">
+                <a:solidFill>
+                  <a:srgbClr val="0F766E"/>
+                </a:solidFill>
+                <a:latin typeface="Calibri"/>
+              </a:rPr>
+              <a:t>•   </a:t>
+            </a:r>
             <a:r>
               <a:rPr sz="1200" b="0" i="0" dirty="0">
                 <a:solidFill>
@@ -4135,7 +4178,143 @@
                 </a:solidFill>
                 <a:latin typeface="Calibri"/>
               </a:rPr>
-              <a:t>Longitudinal follow-up study  |  per-rider RULA observations (eliminate the severity-rank merge)  |  wearable-accelerometer Vibration proxy  |  periodic re-training as the workforce evolves.</a:t>
+              <a:t>Longitudinal follow-up on the same riders over multiple shifts.</a:t>
+            </a:r>
+          </a:p>
+          <a:p>
+            <a:pPr algn="l">
+              <a:lnSpc>
+                <a:spcPct val="150000"/>
+              </a:lnSpc>
+            </a:pPr>
+            <a:r>
+              <a:rPr sz="1200" b="1" i="0" dirty="0">
+                <a:solidFill>
+                  <a:srgbClr val="0F766E"/>
+                </a:solidFill>
+                <a:latin typeface="Calibri"/>
+              </a:rPr>
+              <a:t>•   </a:t>
+            </a:r>
+            <a:r>
+              <a:rPr sz="1200" b="0" i="0" dirty="0">
+                <a:solidFill>
+                  <a:srgbClr val="1F2A40"/>
+                </a:solidFill>
+                <a:latin typeface="Calibri"/>
+              </a:rPr>
+              <a:t>Direct per-rider RULA observations (no rank matching).</a:t>
+            </a:r>
+          </a:p>
+          <a:p>
+            <a:pPr algn="l">
+              <a:lnSpc>
+                <a:spcPct val="150000"/>
+              </a:lnSpc>
+            </a:pPr>
+            <a:r>
+              <a:rPr sz="1200" b="1" i="0" dirty="0">
+                <a:solidFill>
+                  <a:srgbClr val="0F766E"/>
+                </a:solidFill>
+                <a:latin typeface="Calibri"/>
+              </a:rPr>
+              <a:t>•   </a:t>
+            </a:r>
+            <a:r>
+              <a:rPr sz="1200" b="0" i="0" dirty="0">
+                <a:solidFill>
+                  <a:srgbClr val="1F2A40"/>
+                </a:solidFill>
+                <a:latin typeface="Calibri"/>
+              </a:rPr>
+              <a:t>Wearable sensors for Vibration and Duration.</a:t>
+            </a:r>
+          </a:p>
+          <a:p>
+            <a:pPr algn="l">
+              <a:lnSpc>
+                <a:spcPct val="150000"/>
+              </a:lnSpc>
+            </a:pPr>
+            <a:r>
+              <a:rPr sz="1200" b="1" i="0" dirty="0">
+                <a:solidFill>
+                  <a:srgbClr val="0F766E"/>
+                </a:solidFill>
+                <a:latin typeface="Calibri"/>
+              </a:rPr>
+              <a:t>•   </a:t>
+            </a:r>
+            <a:r>
+              <a:rPr sz="1200" b="0" i="0" dirty="0">
+                <a:solidFill>
+                  <a:srgbClr val="1F2A40"/>
+                </a:solidFill>
+                <a:latin typeface="Calibri"/>
+              </a:rPr>
+              <a:t>Larger, multi-city sample beyond Chennai / Chengalpattu.</a:t>
+            </a:r>
+          </a:p>
+          <a:p>
+            <a:pPr algn="l">
+              <a:lnSpc>
+                <a:spcPct val="150000"/>
+              </a:lnSpc>
+            </a:pPr>
+            <a:r>
+              <a:rPr sz="1200" b="1" i="0" dirty="0">
+                <a:solidFill>
+                  <a:srgbClr val="0F766E"/>
+                </a:solidFill>
+                <a:latin typeface="Calibri"/>
+              </a:rPr>
+              <a:t>•   </a:t>
+            </a:r>
+            <a:r>
+              <a:rPr sz="1200" b="0" i="0" dirty="0">
+                <a:solidFill>
+                  <a:srgbClr val="1F2A40"/>
+                </a:solidFill>
+                <a:latin typeface="Calibri"/>
+              </a:rPr>
+              <a:t>Screening integrated into the </a:t>
+            </a:r>
+            <a:r>
+              <a:rPr sz="1200" b="0" i="0" dirty="0" err="1">
+                <a:solidFill>
+                  <a:srgbClr val="1F2A40"/>
+                </a:solidFill>
+                <a:latin typeface="Calibri"/>
+              </a:rPr>
+              <a:t>Blinkit</a:t>
+            </a:r>
+            <a:r>
+              <a:rPr sz="1200" b="0" i="0" dirty="0">
+                <a:solidFill>
+                  <a:srgbClr val="1F2A40"/>
+                </a:solidFill>
+                <a:latin typeface="Calibri"/>
+              </a:rPr>
+              <a:t> / </a:t>
+            </a:r>
+            <a:r>
+              <a:rPr sz="1200" b="0" i="0" dirty="0" err="1">
+                <a:solidFill>
+                  <a:srgbClr val="1F2A40"/>
+                </a:solidFill>
+                <a:latin typeface="Calibri"/>
+              </a:rPr>
+              <a:t>Zepto</a:t>
+            </a:r>
+            <a:r>
+              <a:rPr sz="1200" b="0" i="0" dirty="0">
+                <a:solidFill>
+                  <a:srgbClr val="1F2A40"/>
+                </a:solidFill>
+                <a:latin typeface="Calibri"/>
+              </a:rPr>
+              <a:t> rider app.</a:t>
             </a:r>
           </a:p>
         </p:txBody>
@@ -4174,6 +4353,40 @@
           </a:p>
         </p:txBody>
       </p:sp>
+      <p:sp>
+        <p:nvSpPr>
+          <p:cNvPr id="14" name="TextBox 13"/>
+          <p:cNvSpPr txBox="1"/>
+          <p:nvPr/>
+        </p:nvSpPr>
+        <p:spPr>
+          <a:xfrm>
+            <a:off x="6492240" y="4617720"/>
+            <a:ext cx="5212080" cy="274320"/>
+          </a:xfrm>
+          <a:prstGeom prst="rect">
+            <a:avLst/>
+          </a:prstGeom>
+          <a:noFill/>
+        </p:spPr>
+        <p:txBody>
+          <a:bodyPr wrap="square">
+            <a:spAutoFit/>
+          </a:bodyPr>
+          <a:lstStyle/>
+          <a:p>
+            <a:r>
+              <a:rPr sz="900" i="1">
+                <a:solidFill>
+                  <a:srgbClr val="6B7282"/>
+                </a:solidFill>
+                <a:latin typeface="Calibri"/>
+              </a:rPr>
+              <a:t>Backing numbers: 49% of riders work &gt; 8 h/day · 84% at RULA grand score 5+ · age OR 3.58 · workload and fatigue significant LR predictors.</a:t>
+            </a:r>
+          </a:p>
+        </p:txBody>
+      </p:sp>
     </p:spTree>
   </p:cSld>
   <p:clrMapOvr>
@@ -4182,7 +4395,7 @@
 </p:sld>
 </file>
 
-<file path=ppt/slides/slide2.xml><?xml version="1.0" encoding="utf-8"?>
+<file path=ppt/slides/slide11.xml><?xml version="1.0" encoding="utf-8"?>
 <p:sld xmlns:a="http://schemas.openxmlformats.org/drawingml/2006/main" xmlns:r="http://schemas.openxmlformats.org/officeDocument/2006/relationships" xmlns:p="http://schemas.openxmlformats.org/presentationml/2006/main">
   <p:cSld>
     <p:spTree>
@@ -4252,8 +4465,8 @@
         </p:nvSpPr>
         <p:spPr>
           <a:xfrm>
-            <a:off x="640080" y="384048"/>
-            <a:ext cx="320040" cy="45720"/>
+            <a:off x="640080" y="640080"/>
+            <a:ext cx="822960" cy="109728"/>
           </a:xfrm>
           <a:prstGeom prst="rect">
             <a:avLst/>
@@ -4297,8 +4510,8 @@
         </p:nvSpPr>
         <p:spPr>
           <a:xfrm>
-            <a:off x="640080" y="502920"/>
-            <a:ext cx="10789920" cy="274320"/>
+            <a:off x="640080" y="868680"/>
+            <a:ext cx="3456524" cy="276999"/>
           </a:xfrm>
           <a:prstGeom prst="rect">
             <a:avLst/>
@@ -4312,13 +4525,13 @@
           <a:lstStyle/>
           <a:p>
             <a:r>
-              <a:rPr sz="1000" b="1" i="0">
+              <a:rPr sz="1200" b="1" i="0" dirty="0">
                 <a:solidFill>
                   <a:srgbClr val="0F766E"/>
                 </a:solidFill>
                 <a:latin typeface="Calibri"/>
               </a:rPr>
-              <a:t>01  BACKGROUND</a:t>
+              <a:t>THANK YOU  |  QUESTIONS</a:t>
             </a:r>
           </a:p>
         </p:txBody>
@@ -4331,8 +4544,8 @@
         </p:nvSpPr>
         <p:spPr>
           <a:xfrm>
-            <a:off x="640080" y="777240"/>
-            <a:ext cx="10789920" cy="822960"/>
+            <a:off x="640080" y="1554480"/>
+            <a:ext cx="10789920" cy="2743200"/>
           </a:xfrm>
           <a:prstGeom prst="rect">
             <a:avLst/>
@@ -4340,33 +4553,109 @@
           <a:noFill/>
         </p:spPr>
         <p:txBody>
-          <a:bodyPr wrap="none">
+          <a:bodyPr wrap="square">
             <a:spAutoFit/>
           </a:bodyPr>
           <a:lstStyle/>
           <a:p>
-            <a:r>
-              <a:rPr sz="3200" b="1" i="0">
+            <a:pPr>
+              <a:spcAft>
+                <a:spcPts val="400"/>
+              </a:spcAft>
+            </a:pPr>
+            <a:r>
+              <a:rPr sz="3600" b="1" i="0" dirty="0">
                 <a:solidFill>
                   <a:srgbClr val="0F1F3A"/>
                 </a:solidFill>
                 <a:latin typeface="Calibri"/>
               </a:rPr>
-              <a:t>Problem and Objectives</a:t>
-            </a:r>
-          </a:p>
-        </p:txBody>
-      </p:sp>
-      <p:sp>
-        <p:nvSpPr>
-          <p:cNvPr id="6" name="TextBox 5"/>
+              <a:t>Questions and Discussion</a:t>
+            </a:r>
+          </a:p>
+          <a:p>
+            <a:pPr>
+              <a:spcAft>
+                <a:spcPts val="400"/>
+              </a:spcAft>
+            </a:pPr>
+            <a:endParaRPr sz="3600" b="1" i="0" dirty="0">
+              <a:solidFill>
+                <a:srgbClr val="0F1F3A"/>
+              </a:solidFill>
+              <a:latin typeface="Calibri"/>
+            </a:endParaRPr>
+          </a:p>
+          <a:p>
+            <a:pPr>
+              <a:spcAft>
+                <a:spcPts val="400"/>
+              </a:spcAft>
+            </a:pPr>
+            <a:endParaRPr sz="3600" b="1" i="0" dirty="0">
+              <a:solidFill>
+                <a:srgbClr val="0F1F3A"/>
+              </a:solidFill>
+              <a:latin typeface="Calibri"/>
+            </a:endParaRPr>
+          </a:p>
+        </p:txBody>
+      </p:sp>
+      <p:sp>
+        <p:nvSpPr>
+          <p:cNvPr id="6" name="Rectangle 5"/>
+          <p:cNvSpPr/>
+          <p:nvPr/>
+        </p:nvSpPr>
+        <p:spPr>
+          <a:xfrm>
+            <a:off x="640080" y="4297680"/>
+            <a:ext cx="2743200" cy="18288"/>
+          </a:xfrm>
+          <a:prstGeom prst="rect">
+            <a:avLst/>
+          </a:prstGeom>
+          <a:solidFill>
+            <a:srgbClr val="0F1F3A"/>
+          </a:solidFill>
+          <a:ln>
+            <a:noFill/>
+          </a:ln>
+          <a:effectLst/>
+        </p:spPr>
+        <p:style>
+          <a:lnRef idx="1">
+            <a:schemeClr val="accent1"/>
+          </a:lnRef>
+          <a:fillRef idx="3">
+            <a:schemeClr val="accent1"/>
+          </a:fillRef>
+          <a:effectRef idx="2">
+            <a:schemeClr val="accent1"/>
+          </a:effectRef>
+          <a:fontRef idx="minor">
+            <a:schemeClr val="lt1"/>
+          </a:fontRef>
+        </p:style>
+        <p:txBody>
+          <a:bodyPr rtlCol="0" anchor="ctr"/>
+          <a:lstStyle/>
+          <a:p>
+            <a:pPr algn="ctr"/>
+            <a:endParaRPr/>
+          </a:p>
+        </p:txBody>
+      </p:sp>
+      <p:sp>
+        <p:nvSpPr>
+          <p:cNvPr id="8" name="TextBox 7"/>
           <p:cNvSpPr txBox="1"/>
           <p:nvPr/>
         </p:nvSpPr>
         <p:spPr>
           <a:xfrm>
-            <a:off x="640080" y="1691640"/>
-            <a:ext cx="10789920" cy="1371600"/>
+            <a:off x="640080" y="6400800"/>
+            <a:ext cx="1402948" cy="261610"/>
           </a:xfrm>
           <a:prstGeom prst="rect">
             <a:avLst/>
@@ -4374,176 +4663,19 @@
           <a:noFill/>
         </p:spPr>
         <p:txBody>
-          <a:bodyPr wrap="square">
-            <a:spAutoFit/>
-          </a:bodyPr>
-          <a:lstStyle/>
-          <a:p>
-            <a:pPr algn="l"/>
-            <a:r>
-              <a:rPr sz="1500" b="0" i="0">
-                <a:solidFill>
-                  <a:srgbClr val="1F2A40"/>
-                </a:solidFill>
-                <a:latin typeface="Calibri"/>
-              </a:rPr>
-              <a:t>India's 10-minute delivery boom runs on riders whose bodies quietly pay the price. Every shift is 8+ hours on the bike, heavy packages on the stairs, awkward postures in stop-and-go traffic, and constant vibration, all on the clock set by the platform's routing algorithm. Trip after trip, day after day, the exposure adds up as back pain, shoulder pain, wrist injuries, and knee problems long before the rider reports them. Yet no single screening tool measures a rider's risk across all six standard ergonomic factors (Force, Repetition, Posture, Duration, Contact Stress, Vibration) from one questionnaire.</a:t>
-            </a:r>
-          </a:p>
-        </p:txBody>
-      </p:sp>
-      <p:sp>
-        <p:nvSpPr>
-          <p:cNvPr id="7" name="TextBox 6"/>
-          <p:cNvSpPr txBox="1"/>
-          <p:nvPr/>
-        </p:nvSpPr>
-        <p:spPr>
-          <a:xfrm>
-            <a:off x="640080" y="3291840"/>
-            <a:ext cx="10789920" cy="365760"/>
-          </a:xfrm>
-          <a:prstGeom prst="rect">
-            <a:avLst/>
-          </a:prstGeom>
-          <a:noFill/>
-        </p:spPr>
-        <p:txBody>
-          <a:bodyPr wrap="square">
-            <a:spAutoFit/>
-          </a:bodyPr>
-          <a:lstStyle/>
-          <a:p>
-            <a:pPr algn="l"/>
-            <a:r>
-              <a:rPr sz="1700" b="1" i="0">
-                <a:solidFill>
-                  <a:srgbClr val="0F1F3A"/>
-                </a:solidFill>
-                <a:latin typeface="Calibri"/>
-              </a:rPr>
-              <a:t>Objectives</a:t>
-            </a:r>
-          </a:p>
-        </p:txBody>
-      </p:sp>
-      <p:sp>
-        <p:nvSpPr>
-          <p:cNvPr id="8" name="TextBox 7"/>
-          <p:cNvSpPr txBox="1"/>
-          <p:nvPr/>
-        </p:nvSpPr>
-        <p:spPr>
-          <a:xfrm>
-            <a:off x="640080" y="3749039"/>
-            <a:ext cx="10789920" cy="1615827"/>
-          </a:xfrm>
-          <a:prstGeom prst="rect">
-            <a:avLst/>
-          </a:prstGeom>
-          <a:noFill/>
-        </p:spPr>
-        <p:txBody>
-          <a:bodyPr wrap="square">
-            <a:spAutoFit/>
-          </a:bodyPr>
-          <a:lstStyle/>
-          <a:p>
-            <a:pPr algn="l">
-              <a:spcAft>
-                <a:spcPts val="600"/>
-              </a:spcAft>
-            </a:pPr>
-            <a:r>
-              <a:rPr sz="1400" b="1" i="0" dirty="0">
-                <a:solidFill>
-                  <a:srgbClr val="0F766E"/>
-                </a:solidFill>
-                <a:latin typeface="Calibri"/>
-              </a:rPr>
-              <a:t>•   Combine standard ergonomic methods (RULA, QEC, NMQ, NASA-TLX, Borg CR10) into per-rider Low / Medium / High labels for the six standard risk factors: Force, Repetition, Posture, Duration, Contact Stress, and Vibration.</a:t>
-            </a:r>
-          </a:p>
-          <a:p>
-            <a:pPr algn="l">
-              <a:spcAft>
-                <a:spcPts val="600"/>
-              </a:spcAft>
-            </a:pPr>
-            <a:r>
-              <a:rPr sz="1400" b="1" i="0" dirty="0">
-                <a:solidFill>
-                  <a:srgbClr val="0F766E"/>
-                </a:solidFill>
-                <a:latin typeface="Calibri"/>
-              </a:rPr>
-              <a:t>•   Train an ML model per factor on the 36-item rider survey plus the RULA and QEC observation set, tuned via 5-fold stratified cross-validation with SMOTE, and report per-target accuracy, macro F1, and macro AUC.</a:t>
-            </a:r>
-          </a:p>
-          <a:p>
-            <a:pPr algn="l">
-              <a:spcAft>
-                <a:spcPts val="600"/>
-              </a:spcAft>
-            </a:pPr>
-            <a:r>
-              <a:rPr sz="1400" b="1" i="0" dirty="0">
-                <a:solidFill>
-                  <a:srgbClr val="0F766E"/>
-                </a:solidFill>
-                <a:latin typeface="Calibri"/>
-              </a:rPr>
-              <a:t>•   Deploy a Streamlit web app that accepts a new rider's questionnaire (plus RULA and QEC scores) and returns colour-coded Low / Medium / High predictions across the six factors in real time.</a:t>
-            </a:r>
-          </a:p>
-          <a:p>
-            <a:pPr algn="l">
-              <a:spcAft>
-                <a:spcPts val="600"/>
-              </a:spcAft>
-            </a:pPr>
-            <a:r>
-              <a:rPr sz="1400" b="1" i="0" dirty="0">
-                <a:solidFill>
-                  <a:srgbClr val="0F766E"/>
-                </a:solidFill>
-                <a:latin typeface="Calibri"/>
-              </a:rPr>
-              <a:t>•   Translate the analysis into platform-level actions on working hours, vehicle type, carrying mode, and age-cohort screening.</a:t>
-            </a:r>
-          </a:p>
-        </p:txBody>
-      </p:sp>
-      <p:sp>
-        <p:nvSpPr>
-          <p:cNvPr id="9" name="TextBox 8"/>
-          <p:cNvSpPr txBox="1"/>
-          <p:nvPr/>
-        </p:nvSpPr>
-        <p:spPr>
-          <a:xfrm>
-            <a:off x="640080" y="6446520"/>
-            <a:ext cx="10789920" cy="274320"/>
-          </a:xfrm>
-          <a:prstGeom prst="rect">
-            <a:avLst/>
-          </a:prstGeom>
-          <a:noFill/>
-        </p:spPr>
-        <p:txBody>
           <a:bodyPr wrap="none">
             <a:spAutoFit/>
           </a:bodyPr>
           <a:lstStyle/>
           <a:p>
             <a:r>
-              <a:rPr sz="1000" b="0" i="0">
+              <a:rPr sz="1100" b="0" i="1" dirty="0">
                 <a:solidFill>
                   <a:srgbClr val="6B7282"/>
                 </a:solidFill>
                 <a:latin typeface="Calibri"/>
               </a:rPr>
-              <a:t>A Predictive ML Framework for Ergonomic Risk in Last-Mile Quick-Commerce Delivery Operations   |   Slide 2/10</a:t>
+              <a:t>Aila Vishnu Vardhan </a:t>
             </a:r>
           </a:p>
         </p:txBody>
@@ -4556,7 +4688,7 @@
 </p:sld>
 </file>
 
-<file path=ppt/slides/slide3.xml><?xml version="1.0" encoding="utf-8"?>
+<file path=ppt/slides/slide2.xml><?xml version="1.0" encoding="utf-8"?>
 <p:sld xmlns:a="http://schemas.openxmlformats.org/drawingml/2006/main" xmlns:r="http://schemas.openxmlformats.org/officeDocument/2006/relationships" xmlns:p="http://schemas.openxmlformats.org/presentationml/2006/main">
   <p:cSld>
     <p:spTree>
@@ -4692,7 +4824,7 @@
                 </a:solidFill>
                 <a:latin typeface="Calibri"/>
               </a:rPr>
-              <a:t>02  METHODOLOGY</a:t>
+              <a:t>01  BACKGROUND</a:t>
             </a:r>
           </a:p>
         </p:txBody>
@@ -4726,6 +4858,416 @@
                 </a:solidFill>
                 <a:latin typeface="Calibri"/>
               </a:rPr>
+              <a:t>Problem and Objectives</a:t>
+            </a:r>
+          </a:p>
+        </p:txBody>
+      </p:sp>
+      <p:sp>
+        <p:nvSpPr>
+          <p:cNvPr id="6" name="TextBox 5"/>
+          <p:cNvSpPr txBox="1"/>
+          <p:nvPr/>
+        </p:nvSpPr>
+        <p:spPr>
+          <a:xfrm>
+            <a:off x="640080" y="1691640"/>
+            <a:ext cx="10789920" cy="1371600"/>
+          </a:xfrm>
+          <a:prstGeom prst="rect">
+            <a:avLst/>
+          </a:prstGeom>
+          <a:noFill/>
+        </p:spPr>
+        <p:txBody>
+          <a:bodyPr wrap="square">
+            <a:spAutoFit/>
+          </a:bodyPr>
+          <a:lstStyle/>
+          <a:p>
+            <a:pPr algn="l"/>
+            <a:r>
+              <a:rPr sz="1500" b="0" i="0">
+                <a:solidFill>
+                  <a:srgbClr val="1F2A40"/>
+                </a:solidFill>
+                <a:latin typeface="Calibri"/>
+              </a:rPr>
+              <a:t>India's 10-minute delivery boom runs on riders whose bodies quietly pay the price. Every shift is 8+ hours on the bike, heavy packages on the stairs, awkward postures in stop-and-go traffic, and constant vibration, all on the clock set by the platform's routing algorithm. Trip after trip, day after day, the exposure adds up as back pain, shoulder pain, wrist injuries, and knee problems long before the rider reports them. Yet no single screening tool measures a rider's risk across all six standard ergonomic factors (Force, Repetition, Posture, Duration, Contact Stress, Vibration) from one questionnaire.</a:t>
+            </a:r>
+          </a:p>
+        </p:txBody>
+      </p:sp>
+      <p:sp>
+        <p:nvSpPr>
+          <p:cNvPr id="7" name="TextBox 6"/>
+          <p:cNvSpPr txBox="1"/>
+          <p:nvPr/>
+        </p:nvSpPr>
+        <p:spPr>
+          <a:xfrm>
+            <a:off x="640080" y="3291840"/>
+            <a:ext cx="10789920" cy="365760"/>
+          </a:xfrm>
+          <a:prstGeom prst="rect">
+            <a:avLst/>
+          </a:prstGeom>
+          <a:noFill/>
+        </p:spPr>
+        <p:txBody>
+          <a:bodyPr wrap="square">
+            <a:spAutoFit/>
+          </a:bodyPr>
+          <a:lstStyle/>
+          <a:p>
+            <a:pPr algn="l"/>
+            <a:r>
+              <a:rPr sz="1700" b="1" i="0">
+                <a:solidFill>
+                  <a:srgbClr val="0F1F3A"/>
+                </a:solidFill>
+                <a:latin typeface="Calibri"/>
+              </a:rPr>
+              <a:t>Objectives</a:t>
+            </a:r>
+          </a:p>
+        </p:txBody>
+      </p:sp>
+      <p:sp>
+        <p:nvSpPr>
+          <p:cNvPr id="8" name="TextBox 7"/>
+          <p:cNvSpPr txBox="1"/>
+          <p:nvPr/>
+        </p:nvSpPr>
+        <p:spPr>
+          <a:xfrm>
+            <a:off x="640080" y="3749039"/>
+            <a:ext cx="10789920" cy="1615827"/>
+          </a:xfrm>
+          <a:prstGeom prst="rect">
+            <a:avLst/>
+          </a:prstGeom>
+          <a:noFill/>
+        </p:spPr>
+        <p:txBody>
+          <a:bodyPr wrap="square">
+            <a:spAutoFit/>
+          </a:bodyPr>
+          <a:lstStyle/>
+          <a:p>
+            <a:pPr algn="l">
+              <a:spcAft>
+                <a:spcPts val="600"/>
+              </a:spcAft>
+            </a:pPr>
+            <a:r>
+              <a:rPr sz="1300" b="1" i="0">
+                <a:solidFill>
+                  <a:srgbClr val="0F766E"/>
+                </a:solidFill>
+                <a:latin typeface="Calibri"/>
+              </a:rPr>
+              <a:t>•   </a:t>
+            </a:r>
+            <a:r>
+              <a:rPr sz="1300" b="0" i="0">
+                <a:solidFill>
+                  <a:srgbClr val="1F2A40"/>
+                </a:solidFill>
+                <a:latin typeface="Calibri"/>
+              </a:rPr>
+              <a:t>Combine standard ergonomic methods (RULA, QEC, NMQ, NASA-TLX, Borg CR10) into per-rider Low / Medium / High labels for the six standard risk factors: Force, Repetition, Posture, Duration, Contact Stress, and Vibration.</a:t>
+            </a:r>
+          </a:p>
+          <a:p>
+            <a:pPr algn="l">
+              <a:spcAft>
+                <a:spcPts val="600"/>
+              </a:spcAft>
+            </a:pPr>
+            <a:r>
+              <a:rPr sz="1300" b="1" i="0">
+                <a:solidFill>
+                  <a:srgbClr val="0F766E"/>
+                </a:solidFill>
+                <a:latin typeface="Calibri"/>
+              </a:rPr>
+              <a:t>•   </a:t>
+            </a:r>
+            <a:r>
+              <a:rPr sz="1300" b="0" i="0">
+                <a:solidFill>
+                  <a:srgbClr val="1F2A40"/>
+                </a:solidFill>
+                <a:latin typeface="Calibri"/>
+              </a:rPr>
+              <a:t>Train an ML model per factor on the 36-item rider survey plus the RULA and QEC observation set, tuned via 5-fold stratified cross-validation with SMOTE, and report per-target accuracy, macro F1, and macro AUC.</a:t>
+            </a:r>
+          </a:p>
+          <a:p>
+            <a:pPr algn="l">
+              <a:spcAft>
+                <a:spcPts val="600"/>
+              </a:spcAft>
+            </a:pPr>
+            <a:r>
+              <a:rPr sz="1300" b="1" i="0">
+                <a:solidFill>
+                  <a:srgbClr val="0F766E"/>
+                </a:solidFill>
+                <a:latin typeface="Calibri"/>
+              </a:rPr>
+              <a:t>•   </a:t>
+            </a:r>
+            <a:r>
+              <a:rPr sz="1300" b="0" i="0">
+                <a:solidFill>
+                  <a:srgbClr val="1F2A40"/>
+                </a:solidFill>
+                <a:latin typeface="Calibri"/>
+              </a:rPr>
+              <a:t>Deploy a Streamlit web app that accepts a new rider's questionnaire (plus RULA and QEC scores) and returns colour-coded Low / Medium / High predictions across the six factors in real time.</a:t>
+            </a:r>
+          </a:p>
+          <a:p>
+            <a:pPr algn="l">
+              <a:spcAft>
+                <a:spcPts val="600"/>
+              </a:spcAft>
+            </a:pPr>
+            <a:r>
+              <a:rPr sz="1300" b="1" i="0">
+                <a:solidFill>
+                  <a:srgbClr val="0F766E"/>
+                </a:solidFill>
+                <a:latin typeface="Calibri"/>
+              </a:rPr>
+              <a:t>•   </a:t>
+            </a:r>
+            <a:r>
+              <a:rPr sz="1300" b="0" i="0">
+                <a:solidFill>
+                  <a:srgbClr val="1F2A40"/>
+                </a:solidFill>
+                <a:latin typeface="Calibri"/>
+              </a:rPr>
+              <a:t>Translate the analysis into platform-level actions on working hours, vehicle type, carrying mode, and age-cohort screening.</a:t>
+            </a:r>
+          </a:p>
+        </p:txBody>
+      </p:sp>
+      <p:sp>
+        <p:nvSpPr>
+          <p:cNvPr id="9" name="TextBox 8"/>
+          <p:cNvSpPr txBox="1"/>
+          <p:nvPr/>
+        </p:nvSpPr>
+        <p:spPr>
+          <a:xfrm>
+            <a:off x="640080" y="6446520"/>
+            <a:ext cx="10789920" cy="274320"/>
+          </a:xfrm>
+          <a:prstGeom prst="rect">
+            <a:avLst/>
+          </a:prstGeom>
+          <a:noFill/>
+        </p:spPr>
+        <p:txBody>
+          <a:bodyPr wrap="none">
+            <a:spAutoFit/>
+          </a:bodyPr>
+          <a:lstStyle/>
+          <a:p>
+            <a:r>
+              <a:rPr sz="1000" b="0" i="0">
+                <a:solidFill>
+                  <a:srgbClr val="6B7282"/>
+                </a:solidFill>
+                <a:latin typeface="Calibri"/>
+              </a:rPr>
+              <a:t>A Predictive ML Framework for Ergonomic Risk in Last-Mile Quick-Commerce Delivery Operations   |   Slide 2/10</a:t>
+            </a:r>
+          </a:p>
+        </p:txBody>
+      </p:sp>
+    </p:spTree>
+  </p:cSld>
+  <p:clrMapOvr>
+    <a:masterClrMapping/>
+  </p:clrMapOvr>
+</p:sld>
+</file>
+
+<file path=ppt/slides/slide3.xml><?xml version="1.0" encoding="utf-8"?>
+<p:sld xmlns:a="http://schemas.openxmlformats.org/drawingml/2006/main" xmlns:r="http://schemas.openxmlformats.org/officeDocument/2006/relationships" xmlns:p="http://schemas.openxmlformats.org/presentationml/2006/main">
+  <p:cSld>
+    <p:spTree>
+      <p:nvGrpSpPr>
+        <p:cNvPr id="1" name=""/>
+        <p:cNvGrpSpPr/>
+        <p:nvPr/>
+      </p:nvGrpSpPr>
+      <p:grpSpPr>
+        <a:xfrm>
+          <a:off x="0" y="0"/>
+          <a:ext cx="0" cy="0"/>
+          <a:chOff x="0" y="0"/>
+          <a:chExt cx="0" cy="0"/>
+        </a:xfrm>
+      </p:grpSpPr>
+      <p:sp>
+        <p:nvSpPr>
+          <p:cNvPr id="2" name="Rectangle 1"/>
+          <p:cNvSpPr/>
+          <p:nvPr/>
+        </p:nvSpPr>
+        <p:spPr>
+          <a:xfrm>
+            <a:off x="0" y="0"/>
+            <a:ext cx="12191695" cy="6858000"/>
+          </a:xfrm>
+          <a:prstGeom prst="rect">
+            <a:avLst/>
+          </a:prstGeom>
+          <a:solidFill>
+            <a:srgbClr val="FFFFFF"/>
+          </a:solidFill>
+          <a:ln>
+            <a:noFill/>
+          </a:ln>
+          <a:effectLst/>
+        </p:spPr>
+        <p:style>
+          <a:lnRef idx="1">
+            <a:schemeClr val="accent1"/>
+          </a:lnRef>
+          <a:fillRef idx="3">
+            <a:schemeClr val="accent1"/>
+          </a:fillRef>
+          <a:effectRef idx="2">
+            <a:schemeClr val="accent1"/>
+          </a:effectRef>
+          <a:fontRef idx="minor">
+            <a:schemeClr val="lt1"/>
+          </a:fontRef>
+        </p:style>
+        <p:txBody>
+          <a:bodyPr rtlCol="0" anchor="ctr"/>
+          <a:lstStyle/>
+          <a:p>
+            <a:pPr algn="ctr"/>
+            <a:endParaRPr/>
+          </a:p>
+        </p:txBody>
+      </p:sp>
+      <p:sp>
+        <p:nvSpPr>
+          <p:cNvPr id="3" name="Rectangle 2"/>
+          <p:cNvSpPr/>
+          <p:nvPr/>
+        </p:nvSpPr>
+        <p:spPr>
+          <a:xfrm>
+            <a:off x="640080" y="384048"/>
+            <a:ext cx="320040" cy="45720"/>
+          </a:xfrm>
+          <a:prstGeom prst="rect">
+            <a:avLst/>
+          </a:prstGeom>
+          <a:solidFill>
+            <a:srgbClr val="0F766E"/>
+          </a:solidFill>
+          <a:ln>
+            <a:noFill/>
+          </a:ln>
+          <a:effectLst/>
+        </p:spPr>
+        <p:style>
+          <a:lnRef idx="1">
+            <a:schemeClr val="accent1"/>
+          </a:lnRef>
+          <a:fillRef idx="3">
+            <a:schemeClr val="accent1"/>
+          </a:fillRef>
+          <a:effectRef idx="2">
+            <a:schemeClr val="accent1"/>
+          </a:effectRef>
+          <a:fontRef idx="minor">
+            <a:schemeClr val="lt1"/>
+          </a:fontRef>
+        </p:style>
+        <p:txBody>
+          <a:bodyPr rtlCol="0" anchor="ctr"/>
+          <a:lstStyle/>
+          <a:p>
+            <a:pPr algn="ctr"/>
+            <a:endParaRPr/>
+          </a:p>
+        </p:txBody>
+      </p:sp>
+      <p:sp>
+        <p:nvSpPr>
+          <p:cNvPr id="4" name="TextBox 3"/>
+          <p:cNvSpPr txBox="1"/>
+          <p:nvPr/>
+        </p:nvSpPr>
+        <p:spPr>
+          <a:xfrm>
+            <a:off x="640080" y="502920"/>
+            <a:ext cx="10789920" cy="274320"/>
+          </a:xfrm>
+          <a:prstGeom prst="rect">
+            <a:avLst/>
+          </a:prstGeom>
+          <a:noFill/>
+        </p:spPr>
+        <p:txBody>
+          <a:bodyPr wrap="none">
+            <a:spAutoFit/>
+          </a:bodyPr>
+          <a:lstStyle/>
+          <a:p>
+            <a:r>
+              <a:rPr sz="1000" b="1" i="0">
+                <a:solidFill>
+                  <a:srgbClr val="0F766E"/>
+                </a:solidFill>
+                <a:latin typeface="Calibri"/>
+              </a:rPr>
+              <a:t>02  METHODOLOGY</a:t>
+            </a:r>
+          </a:p>
+        </p:txBody>
+      </p:sp>
+      <p:sp>
+        <p:nvSpPr>
+          <p:cNvPr id="5" name="TextBox 4"/>
+          <p:cNvSpPr txBox="1"/>
+          <p:nvPr/>
+        </p:nvSpPr>
+        <p:spPr>
+          <a:xfrm>
+            <a:off x="640080" y="777240"/>
+            <a:ext cx="10789920" cy="822960"/>
+          </a:xfrm>
+          <a:prstGeom prst="rect">
+            <a:avLst/>
+          </a:prstGeom>
+          <a:noFill/>
+        </p:spPr>
+        <p:txBody>
+          <a:bodyPr wrap="none">
+            <a:spAutoFit/>
+          </a:bodyPr>
+          <a:lstStyle/>
+          <a:p>
+            <a:r>
+              <a:rPr sz="3200" b="1" i="0">
+                <a:solidFill>
+                  <a:srgbClr val="0F1F3A"/>
+                </a:solidFill>
+                <a:latin typeface="Calibri"/>
+              </a:rPr>
               <a:t>Two-Stage Pipeline</a:t>
             </a:r>
           </a:p>
@@ -4759,7 +5301,7 @@
               </a:spcAft>
             </a:pPr>
             <a:r>
-              <a:rPr sz="1300" b="1" i="0">
+              <a:rPr sz="1300" b="1" i="0" dirty="0">
                 <a:solidFill>
                   <a:srgbClr val="0F766E"/>
                 </a:solidFill>
@@ -4768,7 +5310,7 @@
               <a:t>•   </a:t>
             </a:r>
             <a:r>
-              <a:rPr sz="1300" b="0" i="0">
+              <a:rPr sz="1300" b="0" i="0" dirty="0">
                 <a:solidFill>
                   <a:srgbClr val="1F2A40"/>
                 </a:solidFill>
@@ -4784,7 +5326,7 @@
               </a:spcAft>
             </a:pPr>
             <a:r>
-              <a:rPr sz="1300" b="1" i="0">
+              <a:rPr sz="1300" b="1" i="0" dirty="0">
                 <a:solidFill>
                   <a:srgbClr val="0F766E"/>
                 </a:solidFill>
@@ -4793,7 +5335,7 @@
               <a:t>–   </a:t>
             </a:r>
             <a:r>
-              <a:rPr sz="1300" b="0" i="0">
+              <a:rPr sz="1300" b="0" i="0" dirty="0">
                 <a:solidFill>
                   <a:srgbClr val="1F2A40"/>
                 </a:solidFill>
@@ -4809,7 +5351,7 @@
               </a:spcAft>
             </a:pPr>
             <a:r>
-              <a:rPr sz="1300" b="1" i="0">
+              <a:rPr sz="1300" b="1" i="0" dirty="0">
                 <a:solidFill>
                   <a:srgbClr val="0F766E"/>
                 </a:solidFill>
@@ -4818,7 +5360,7 @@
               <a:t>–   </a:t>
             </a:r>
             <a:r>
-              <a:rPr sz="1300" b="0" i="0">
+              <a:rPr sz="1300" b="0" i="0" dirty="0">
                 <a:solidFill>
                   <a:srgbClr val="1F2A40"/>
                 </a:solidFill>
@@ -4834,7 +5376,7 @@
               </a:spcAft>
             </a:pPr>
             <a:r>
-              <a:rPr sz="1300" b="1" i="0">
+              <a:rPr sz="1300" b="1" i="0" dirty="0">
                 <a:solidFill>
                   <a:srgbClr val="0F766E"/>
                 </a:solidFill>
@@ -4843,7 +5385,7 @@
               <a:t>–   </a:t>
             </a:r>
             <a:r>
-              <a:rPr sz="1300" b="0" i="0">
+              <a:rPr sz="1300" b="0" i="0" dirty="0">
                 <a:solidFill>
                   <a:srgbClr val="1F2A40"/>
                 </a:solidFill>
@@ -4859,7 +5401,7 @@
               </a:spcAft>
             </a:pPr>
             <a:r>
-              <a:rPr sz="1300" b="1" i="0">
+              <a:rPr sz="1300" b="1" i="0" dirty="0">
                 <a:solidFill>
                   <a:srgbClr val="0F766E"/>
                 </a:solidFill>
@@ -4868,7 +5410,7 @@
               <a:t>–   </a:t>
             </a:r>
             <a:r>
-              <a:rPr sz="1300" b="0" i="0">
+              <a:rPr sz="1300" b="0" i="0" dirty="0">
                 <a:solidFill>
                   <a:srgbClr val="1F2A40"/>
                 </a:solidFill>
@@ -4884,7 +5426,7 @@
               </a:spcAft>
             </a:pPr>
             <a:r>
-              <a:rPr sz="1300" b="1" i="0">
+              <a:rPr sz="1300" b="1" i="0" dirty="0">
                 <a:solidFill>
                   <a:srgbClr val="0F766E"/>
                 </a:solidFill>
@@ -4893,13 +5435,31 @@
               <a:t>•   </a:t>
             </a:r>
             <a:r>
-              <a:rPr sz="1300" b="0" i="0">
+              <a:rPr sz="1300" b="0" i="0" dirty="0">
                 <a:solidFill>
                   <a:srgbClr val="1F2A40"/>
                 </a:solidFill>
                 <a:latin typeface="Calibri"/>
               </a:rPr>
-              <a:t>Stage 2 (supervised ML).  One model per factor learns the Stage-1 label from the rider profile. Inputs used to define the label are excluded so the model cannot just memorise the rule.</a:t>
+              <a:t>Stage 2 (supervised ML).  One model per factor learns the Stage-1 label from the rider profile. Inputs used to define the label are excluded so the model cannot just </a:t>
+            </a:r>
+            <a:r>
+              <a:rPr lang="en-IN" sz="1300" b="0" i="0" dirty="0">
+                <a:solidFill>
+                  <a:srgbClr val="1F2A40"/>
+                </a:solidFill>
+                <a:latin typeface="Calibri"/>
+              </a:rPr>
+              <a:t>memorise</a:t>
+            </a:r>
+            <a:r>
+              <a:rPr sz="1300" b="0" i="0" dirty="0">
+                <a:solidFill>
+                  <a:srgbClr val="1F2A40"/>
+                </a:solidFill>
+                <a:latin typeface="Calibri"/>
+              </a:rPr>
+              <a:t> the rule.</a:t>
             </a:r>
           </a:p>
           <a:p>
@@ -4909,7 +5469,7 @@
               </a:spcAft>
             </a:pPr>
             <a:r>
-              <a:rPr sz="1300" b="1" i="0">
+              <a:rPr sz="1300" b="1" i="0" dirty="0">
                 <a:solidFill>
                   <a:srgbClr val="0F766E"/>
                 </a:solidFill>
@@ -4918,13 +5478,31 @@
               <a:t>•   </a:t>
             </a:r>
             <a:r>
-              <a:rPr sz="1300" b="0" i="0">
+              <a:rPr sz="1300" b="0" i="0" dirty="0">
                 <a:solidFill>
                   <a:srgbClr val="1F2A40"/>
                 </a:solidFill>
                 <a:latin typeface="Calibri"/>
               </a:rPr>
-              <a:t>Trained models run behind a Streamlit form so a new rider gets predictions in seconds.</a:t>
+              <a:t>Trained models run behind a </a:t>
+            </a:r>
+            <a:r>
+              <a:rPr sz="1300" b="0" i="0" dirty="0" err="1">
+                <a:solidFill>
+                  <a:srgbClr val="1F2A40"/>
+                </a:solidFill>
+                <a:latin typeface="Calibri"/>
+              </a:rPr>
+              <a:t>Streamlit</a:t>
+            </a:r>
+            <a:r>
+              <a:rPr sz="1300" b="0" i="0" dirty="0">
+                <a:solidFill>
+                  <a:srgbClr val="1F2A40"/>
+                </a:solidFill>
+                <a:latin typeface="Calibri"/>
+              </a:rPr>
+              <a:t> form so a new rider gets predictions in seconds.</a:t>
             </a:r>
           </a:p>
         </p:txBody>
@@ -5350,7 +5928,7 @@
               </a:spcAft>
             </a:pPr>
             <a:r>
-              <a:rPr sz="1200" b="1" i="0">
+              <a:rPr sz="1200" b="1" i="0" dirty="0">
                 <a:solidFill>
                   <a:srgbClr val="0F766E"/>
                 </a:solidFill>
@@ -5359,7 +5937,7 @@
               <a:t>•   </a:t>
             </a:r>
             <a:r>
-              <a:rPr sz="1200" b="0" i="0">
+              <a:rPr sz="1200" b="0" i="0" dirty="0">
                 <a:solidFill>
                   <a:srgbClr val="1F2A40"/>
                 </a:solidFill>
@@ -5375,7 +5953,7 @@
               </a:spcAft>
             </a:pPr>
             <a:r>
-              <a:rPr sz="1200" b="1" i="0">
+              <a:rPr sz="1200" b="1" i="0" dirty="0">
                 <a:solidFill>
                   <a:srgbClr val="0F766E"/>
                 </a:solidFill>
@@ -5384,7 +5962,7 @@
               <a:t>–   </a:t>
             </a:r>
             <a:r>
-              <a:rPr sz="1200" b="0" i="0">
+              <a:rPr sz="1200" b="0" i="0" dirty="0">
                 <a:solidFill>
                   <a:srgbClr val="1F2A40"/>
                 </a:solidFill>
@@ -5400,7 +5978,7 @@
               </a:spcAft>
             </a:pPr>
             <a:r>
-              <a:rPr sz="1200" b="1" i="0">
+              <a:rPr sz="1200" b="1" i="0" dirty="0">
                 <a:solidFill>
                   <a:srgbClr val="0F766E"/>
                 </a:solidFill>
@@ -5409,7 +5987,7 @@
               <a:t>–   </a:t>
             </a:r>
             <a:r>
-              <a:rPr sz="1200" b="0" i="0">
+              <a:rPr sz="1200" b="0" i="0" dirty="0">
                 <a:solidFill>
                   <a:srgbClr val="1F2A40"/>
                 </a:solidFill>
@@ -5425,13 +6003,22 @@
               </a:spcAft>
             </a:pPr>
             <a:r>
-              <a:rPr sz="1200" b="1" i="0">
+              <a:rPr sz="1200" b="1" i="0" dirty="0">
                 <a:solidFill>
                   <a:srgbClr val="0F766E"/>
                 </a:solidFill>
                 <a:latin typeface="Calibri"/>
               </a:rPr>
-              <a:t>–   Q19: 7-day discomfort (neck, lower back, wrist/hands, knees)</a:t>
+              <a:t>–   </a:t>
+            </a:r>
+            <a:r>
+              <a:rPr sz="1200" b="0" i="0" dirty="0">
+                <a:solidFill>
+                  <a:srgbClr val="1F2A40"/>
+                </a:solidFill>
+                <a:latin typeface="Calibri"/>
+              </a:rPr>
+              <a:t>Q19: 7-day discomfort (neck, lower back, wrist/hands, knees)</a:t>
             </a:r>
           </a:p>
           <a:p>
@@ -5441,7 +6028,7 @@
               </a:spcAft>
             </a:pPr>
             <a:r>
-              <a:rPr sz="1200" b="1" i="0">
+              <a:rPr sz="1200" b="1" i="0" dirty="0">
                 <a:solidFill>
                   <a:srgbClr val="0F766E"/>
                 </a:solidFill>
@@ -5450,7 +6037,7 @@
               <a:t>–   </a:t>
             </a:r>
             <a:r>
-              <a:rPr sz="1200" b="0" i="0">
+              <a:rPr sz="1200" b="0" i="0" dirty="0">
                 <a:solidFill>
                   <a:srgbClr val="1F2A40"/>
                 </a:solidFill>
@@ -5466,7 +6053,7 @@
               </a:spcAft>
             </a:pPr>
             <a:r>
-              <a:rPr sz="1200" b="1" i="0">
+              <a:rPr sz="1200" b="1" i="0" dirty="0">
                 <a:solidFill>
                   <a:srgbClr val="0F766E"/>
                 </a:solidFill>
@@ -5475,7 +6062,7 @@
               <a:t>–   </a:t>
             </a:r>
             <a:r>
-              <a:rPr sz="1200" b="0" i="0">
+              <a:rPr sz="1200" b="0" i="0" dirty="0">
                 <a:solidFill>
                   <a:srgbClr val="1F2A40"/>
                 </a:solidFill>
@@ -5491,7 +6078,7 @@
               </a:spcAft>
             </a:pPr>
             <a:r>
-              <a:rPr sz="1200" b="1" i="0">
+              <a:rPr sz="1200" b="1" i="0" dirty="0">
                 <a:solidFill>
                   <a:srgbClr val="0F766E"/>
                 </a:solidFill>
@@ -5500,7 +6087,7 @@
               <a:t>–   </a:t>
             </a:r>
             <a:r>
-              <a:rPr sz="1200" b="0" i="0">
+              <a:rPr sz="1200" b="0" i="0" dirty="0">
                 <a:solidFill>
                   <a:srgbClr val="1F2A40"/>
                 </a:solidFill>
@@ -5516,7 +6103,7 @@
               </a:spcAft>
             </a:pPr>
             <a:r>
-              <a:rPr sz="1200" b="1" i="0">
+              <a:rPr sz="1200" b="1" i="0" dirty="0">
                 <a:solidFill>
                   <a:srgbClr val="0F766E"/>
                 </a:solidFill>
@@ -5525,7 +6112,7 @@
               <a:t>•   </a:t>
             </a:r>
             <a:r>
-              <a:rPr sz="1200" b="0" i="0">
+              <a:rPr sz="1200" b="0" i="0" dirty="0">
                 <a:solidFill>
                   <a:srgbClr val="1F2A40"/>
                 </a:solidFill>
@@ -9508,7 +10095,7 @@
         </p:nvGraphicFramePr>
         <p:xfrm>
           <a:off x="640080" y="4343400"/>
-          <a:ext cx="5394960" cy="1600200"/>
+          <a:ext cx="5394960" cy="1706880"/>
         </p:xfrm>
         <a:graphic>
           <a:graphicData uri="http://schemas.openxmlformats.org/drawingml/2006/table">
@@ -10456,7 +11043,7 @@
         </p:nvGraphicFramePr>
         <p:xfrm>
           <a:off x="6400800" y="4343400"/>
-          <a:ext cx="5303520" cy="1600200"/>
+          <a:ext cx="5303520" cy="1706880"/>
         </p:xfrm>
         <a:graphic>
           <a:graphicData uri="http://schemas.openxmlformats.org/drawingml/2006/table">

</xml_diff>